<commit_message>
Dark glass theme with animated background
- Every page sits on an animated canvas: drifting aurora glows, a moving
  grid and a particle network that links to the mouse (paused when the tab
  is hidden, off for reduced motion, hidden when printing)
- Cards, tables, forms, menus, alerts and badges restyled as frosted dark
  glass with high-contrast text; native controls use the dark colour scheme
- Report and presentation refreshed with dark-theme screenshots and the
  updated colour palette

Co-Authored-By: Claude Opus 5.5 <noreply@anthropic.com>
Claude-Session: https://claude.ai/code/session_01EGrnzrfHztmX7RAaosfXYG
</commit_message>
<xml_diff>
--- a/documentation/Nexus_Documentation/Nexus_Presentation_animated.pptx
+++ b/documentation/Nexus_Documentation/Nexus_Presentation_animated.pptx
@@ -122,26 +122,26 @@
   <p:extLst>
     <p:ext uri="{521415D9-36F7-43E2-AB2F-B90AF26B5E84}">
       <p14:sectionLst xmlns:p14="http://schemas.microsoft.com/office/powerpoint/2010/main">
-        <p14:section name="Introduction" id="{e268a2a8-95da-d611-31e5-9f7c943b3212}">
+        <p14:section name="Introduction" id="{f4af6874-5f95-d15b-347d-22bf2ce94a0b}">
           <p14:sldIdLst>
             <p14:sldId id="256"/>
             <p14:sldId id="257"/>
           </p14:sldIdLst>
         </p14:section>
-        <p14:section name="Problem and solution" id="{f6c1c568-591f-d5e7-b534-18075d67d012}">
+        <p14:section name="Problem and solution" id="{298d7180-c411-c3f9-b460-b2c1f2ed2d25}">
           <p14:sldIdLst>
             <p14:sldId id="258"/>
             <p14:sldId id="259"/>
           </p14:sldIdLst>
         </p14:section>
-        <p14:section name="Design" id="{ff3f86f0-35ae-4aa9-0a9e-2d7c64288928}">
+        <p14:section name="Design" id="{67425f1d-3c55-437c-7f5e-f6d1d83d37cd}">
           <p14:sldIdLst>
             <p14:sldId id="260"/>
             <p14:sldId id="261"/>
             <p14:sldId id="262"/>
           </p14:sldIdLst>
         </p14:section>
-        <p14:section name="Business rules" id="{05214bf9-559b-5d18-3885-0937c6e75366}">
+        <p14:section name="Business rules" id="{180a2c7f-4160-f7c7-d674-76b79fc72fbf}">
           <p14:sldIdLst>
             <p14:sldId id="263"/>
             <p14:sldId id="264"/>
@@ -149,19 +149,19 @@
             <p14:sldId id="266"/>
           </p14:sldIdLst>
         </p14:section>
-        <p14:section name="Interface" id="{d20ee507-e070-56d2-be00-e33cb1d3b898}">
+        <p14:section name="Interface" id="{a0c97f4d-793f-48b9-9b28-dc7d785fe8fe}">
           <p14:sldIdLst>
             <p14:sldId id="267"/>
             <p14:sldId id="268"/>
           </p14:sldIdLst>
         </p14:section>
-        <p14:section name="Quality" id="{a504468f-61e5-dc10-a2f9-69c111fc20ee}">
+        <p14:section name="Quality" id="{1053db42-b9d8-dcf2-1a64-2fd6a2de4975}">
           <p14:sldIdLst>
             <p14:sldId id="269"/>
             <p14:sldId id="270"/>
           </p14:sldIdLst>
         </p14:section>
-        <p14:section name="Close" id="{25d333be-dfb7-dbbc-26f3-6fb1201613dc}">
+        <p14:section name="Close" id="{f3cdece8-d077-4120-6523-08d5e315feda}">
           <p14:sldIdLst>
             <p14:sldId id="271"/>
           </p14:sldIdLst>
@@ -8058,7 +8058,7 @@
                   <a:schemeClr val="tx2"/>
                 </a:solidFill>
               </a:rPr>
-              <a:t>3D parallax hero</a:t>
+              <a:t>Animated dark theme</a:t>
             </a:r>
             <a:endParaRPr lang="en-US" sz="1500" dirty="0"/>
           </a:p>
@@ -8094,7 +8094,7 @@
                   <a:schemeClr val="accent6"/>
                 </a:solidFill>
               </a:rPr>
-              <a:t>Globe, grid and glow layers follow the mouse</a:t>
+              <a:t>Aurora glows and a particle network behind glass cards</a:t>
             </a:r>
             <a:endParaRPr lang="en-US" sz="1250" dirty="0"/>
           </a:p>
@@ -8174,7 +8174,7 @@
                   <a:schemeClr val="tx2"/>
                 </a:solidFill>
               </a:rPr>
-              <a:t>Tilt cards</a:t>
+              <a:t>3D hero and tilt cards</a:t>
             </a:r>
             <a:endParaRPr lang="en-US" sz="1500" dirty="0"/>
           </a:p>
@@ -8210,7 +8210,7 @@
                   <a:schemeClr val="accent6"/>
                 </a:solidFill>
               </a:rPr>
-              <a:t>Cards tilt toward the pointer with a light glare</a:t>
+              <a:t>Parallax globe; cards tilt with a light glare</a:t>
             </a:r>
             <a:endParaRPr lang="en-US" sz="1250" dirty="0"/>
           </a:p>

</xml_diff>

<commit_message>
Documentation: screenshots and design sections updated for the glass theme and clear-glass interactions
Co-Authored-By: Claude Opus 5.5 <noreply@anthropic.com>
Claude-Session: https://claude.ai/code/session_01EGrnzrfHztmX7RAaosfXYG
</commit_message>
<xml_diff>
--- a/documentation/Nexus_Documentation/Nexus_Presentation_animated.pptx
+++ b/documentation/Nexus_Documentation/Nexus_Presentation_animated.pptx
@@ -122,26 +122,26 @@
   <p:extLst>
     <p:ext uri="{521415D9-36F7-43E2-AB2F-B90AF26B5E84}">
       <p14:sectionLst xmlns:p14="http://schemas.microsoft.com/office/powerpoint/2010/main">
-        <p14:section name="Introduction" id="{f4af6874-5f95-d15b-347d-22bf2ce94a0b}">
+        <p14:section name="Introduction" id="{327ce859-87c0-a2a7-b7b2-432a24cc5299}">
           <p14:sldIdLst>
             <p14:sldId id="256"/>
             <p14:sldId id="257"/>
           </p14:sldIdLst>
         </p14:section>
-        <p14:section name="Problem and solution" id="{298d7180-c411-c3f9-b460-b2c1f2ed2d25}">
+        <p14:section name="Problem and solution" id="{71e44aa7-d57e-9d99-1c74-c5a8c9314446}">
           <p14:sldIdLst>
             <p14:sldId id="258"/>
             <p14:sldId id="259"/>
           </p14:sldIdLst>
         </p14:section>
-        <p14:section name="Design" id="{67425f1d-3c55-437c-7f5e-f6d1d83d37cd}">
+        <p14:section name="Design" id="{8a40ffa8-619c-2d6d-3e3e-be8362ebfe3c}">
           <p14:sldIdLst>
             <p14:sldId id="260"/>
             <p14:sldId id="261"/>
             <p14:sldId id="262"/>
           </p14:sldIdLst>
         </p14:section>
-        <p14:section name="Business rules" id="{180a2c7f-4160-f7c7-d674-76b79fc72fbf}">
+        <p14:section name="Business rules" id="{7d7a54ca-1bfb-4494-b649-4515a9933c6d}">
           <p14:sldIdLst>
             <p14:sldId id="263"/>
             <p14:sldId id="264"/>
@@ -149,19 +149,19 @@
             <p14:sldId id="266"/>
           </p14:sldIdLst>
         </p14:section>
-        <p14:section name="Interface" id="{a0c97f4d-793f-48b9-9b28-dc7d785fe8fe}">
+        <p14:section name="Interface" id="{3b5da8fc-a2a0-2d6a-e0e0-94942a7d0a6c}">
           <p14:sldIdLst>
             <p14:sldId id="267"/>
             <p14:sldId id="268"/>
           </p14:sldIdLst>
         </p14:section>
-        <p14:section name="Quality" id="{1053db42-b9d8-dcf2-1a64-2fd6a2de4975}">
+        <p14:section name="Quality" id="{b9cb1bbd-1d93-c40f-8bd2-ea38e4813d99}">
           <p14:sldIdLst>
             <p14:sldId id="269"/>
             <p14:sldId id="270"/>
           </p14:sldIdLst>
         </p14:section>
-        <p14:section name="Close" id="{f3cdece8-d077-4120-6523-08d5e315feda}">
+        <p14:section name="Close" id="{ae1524dc-a634-f29c-6023-7e56c7e60518}">
           <p14:sldIdLst>
             <p14:sldId id="271"/>
           </p14:sldIdLst>
@@ -1110,7 +1110,7 @@
           <a:p>
             <a:r>
               <a:rPr lang="en-US" dirty="0"/>
-              <a:t>The interface uses a custom design system: a 3D parallax hero, tilt cards, smooth page transitions and micro-interactions. Everything respects the reduced-motion setting and works on phones.</a:t>
+              <a:t>The interface uses a custom glass design system: frosted cards over an animated background that turn clear when hovered and press in when clicked, a 3D parallax hero, tilt cards, smooth page transitions and micro-interactions. Everything respects the reduced-motion setting and works on phones.</a:t>
             </a:r>
             <a:endParaRPr lang="en-US" dirty="0"/>
           </a:p>
@@ -7920,7 +7920,7 @@
                   <a:schemeClr val="tx2"/>
                 </a:solidFill>
               </a:rPr>
-              <a:t>A modern interface with 3D motion</a:t>
+              <a:t>A glass interface with 3D motion</a:t>
             </a:r>
             <a:endParaRPr lang="en-US" sz="3200" dirty="0"/>
           </a:p>
@@ -8058,7 +8058,7 @@
                   <a:schemeClr val="tx2"/>
                 </a:solidFill>
               </a:rPr>
-              <a:t>Animated dark theme</a:t>
+              <a:t>Frosted glass theme</a:t>
             </a:r>
             <a:endParaRPr lang="en-US" sz="1500" dirty="0"/>
           </a:p>
@@ -8094,7 +8094,7 @@
                   <a:schemeClr val="accent6"/>
                 </a:solidFill>
               </a:rPr>
-              <a:t>Aurora glows and a particle network behind glass cards</a:t>
+              <a:t>Glass cards over animated aurora glows and particles</a:t>
             </a:r>
             <a:endParaRPr lang="en-US" sz="1250" dirty="0"/>
           </a:p>
@@ -8174,7 +8174,7 @@
                   <a:schemeClr val="tx2"/>
                 </a:solidFill>
               </a:rPr>
-              <a:t>3D hero and tilt cards</a:t>
+              <a:t>Clear glass on hover</a:t>
             </a:r>
             <a:endParaRPr lang="en-US" sz="1500" dirty="0"/>
           </a:p>
@@ -8210,7 +8210,7 @@
                   <a:schemeClr val="accent6"/>
                 </a:solidFill>
               </a:rPr>
-              <a:t>Parallax globe; cards tilt with a light glare</a:t>
+              <a:t>Cards turn clear, light up and tilt; a light flash on click</a:t>
             </a:r>
             <a:endParaRPr lang="en-US" sz="1250" dirty="0"/>
           </a:p>

</xml_diff>

<commit_message>
Documentation: ADSE Semester 3, Aptech Center NN2, system role per team member
Co-Authored-By: Claude Opus 5.5 <noreply@anthropic.com>
Claude-Session: https://claude.ai/code/session_01EGrnzrfHztmX7RAaosfXYG
</commit_message>
<xml_diff>
--- a/documentation/Nexus_Documentation/Nexus_Presentation_animated.pptx
+++ b/documentation/Nexus_Documentation/Nexus_Presentation_animated.pptx
@@ -123,27 +123,27 @@
   <p:extLst>
     <p:ext uri="{521415D9-36F7-43E2-AB2F-B90AF26B5E84}">
       <p14:sectionLst xmlns:p14="http://schemas.microsoft.com/office/powerpoint/2010/main">
-        <p14:section name="Introduction" id="{b3f5d123-1a3d-2dff-be96-845a293f6c1f}">
+        <p14:section name="Introduction" id="{69b7fc02-057b-32ed-569e-693c856a1545}">
           <p14:sldIdLst>
             <p14:sldId id="256"/>
             <p14:sldId id="257"/>
             <p14:sldId id="258"/>
           </p14:sldIdLst>
         </p14:section>
-        <p14:section name="Problem and solution" id="{6a46c6fb-8a0d-5888-a669-06c97fc297e7}">
+        <p14:section name="Problem and solution" id="{12bc3e6b-9695-686a-cf56-9de082ca2526}">
           <p14:sldIdLst>
             <p14:sldId id="259"/>
             <p14:sldId id="260"/>
           </p14:sldIdLst>
         </p14:section>
-        <p14:section name="Design" id="{38bf5e4d-c77d-c876-f1aa-83db6426eda1}">
+        <p14:section name="Design" id="{acf2ded9-c467-1caf-97a7-c7ec278a03c9}">
           <p14:sldIdLst>
             <p14:sldId id="261"/>
             <p14:sldId id="262"/>
             <p14:sldId id="263"/>
           </p14:sldIdLst>
         </p14:section>
-        <p14:section name="Business rules" id="{7b9275da-df37-a21b-c032-27af92bd02f1}">
+        <p14:section name="Business rules" id="{c05eea33-7d08-47f9-f8a6-453961947879}">
           <p14:sldIdLst>
             <p14:sldId id="264"/>
             <p14:sldId id="265"/>
@@ -151,19 +151,19 @@
             <p14:sldId id="267"/>
           </p14:sldIdLst>
         </p14:section>
-        <p14:section name="Interface" id="{23da28bb-2189-858f-5080-c53f9382f180}">
+        <p14:section name="Interface" id="{9f03a7e4-419f-f966-cbe6-272df00f9feb}">
           <p14:sldIdLst>
             <p14:sldId id="268"/>
             <p14:sldId id="269"/>
           </p14:sldIdLst>
         </p14:section>
-        <p14:section name="Quality" id="{3c934f4b-80af-7168-287e-93c6f6aa8910}">
+        <p14:section name="Quality" id="{ba2e0be1-1278-b69d-0f97-2329bed1779e}">
           <p14:sldIdLst>
             <p14:sldId id="270"/>
             <p14:sldId id="271"/>
           </p14:sldIdLst>
         </p14:section>
-        <p14:section name="Close" id="{ba2ecbb7-c4c4-9698-accd-ae381e0fd752}">
+        <p14:section name="Close" id="{e2a2e786-7415-8622-25d8-34c5aa628826}">
           <p14:sldIdLst>
             <p14:sldId id="272"/>
           </p14:sldIdLst>
@@ -1640,7 +1640,7 @@
           <a:p>
             <a:r>
               <a:rPr lang="en-US" dirty="0"/>
-              <a:t>Introduce each member of the group, their main area of work and which part of the presentation they will give.</a:t>
+              <a:t>Introduce each member of the group, the system role they own (Admin, Retail, Technical, Accounts, Customer), their main area of work and which part of the presentation they will give.</a:t>
             </a:r>
             <a:endParaRPr lang="en-US" dirty="0"/>
           </a:p>
@@ -19589,8 +19589,8 @@
         </p:nvSpPr>
         <p:spPr>
           <a:xfrm>
-            <a:off x="685800" y="2788920"/>
-            <a:ext cx="1847088" cy="685800"/>
+            <a:off x="640080" y="2743200"/>
+            <a:ext cx="1938528" cy="640080"/>
           </a:xfrm>
           <a:prstGeom prst="rect">
             <a:avLst/>
@@ -19625,8 +19625,8 @@
         </p:nvSpPr>
         <p:spPr>
           <a:xfrm>
-            <a:off x="685800" y="3474720"/>
-            <a:ext cx="1847088" cy="274320"/>
+            <a:off x="685800" y="3429000"/>
+            <a:ext cx="1847088" cy="256032"/>
           </a:xfrm>
           <a:prstGeom prst="rect">
             <a:avLst/>
@@ -19655,14 +19655,77 @@
       </p:sp>
       <p:sp>
         <p:nvSpPr>
-          <p:cNvPr id="8" name="a-up-w-tmf0"/>
+          <p:cNvPr id="8" name="a-up-w-tmr0"/>
+          <p:cNvSpPr/>
+          <p:nvPr/>
+        </p:nvSpPr>
+        <p:spPr>
+          <a:xfrm>
+            <a:off x="822960" y="3749040"/>
+            <a:ext cx="1572768" cy="329184"/>
+          </a:xfrm>
+          <a:prstGeom prst="roundRect">
+            <a:avLst>
+              <a:gd name="adj" fmla="val 50000"/>
+            </a:avLst>
+          </a:prstGeom>
+          <a:solidFill>
+            <a:schemeClr val="bg2"/>
+          </a:solidFill>
+          <a:ln w="6350">
+            <a:solidFill>
+              <a:srgbClr val="CBD5E1"/>
+            </a:solidFill>
+            <a:prstDash val="solid"/>
+          </a:ln>
+        </p:spPr>
+      </p:sp>
+      <p:sp>
+        <p:nvSpPr>
+          <p:cNvPr id="9" name="a-up-w-tmrt0"/>
           <p:cNvSpPr txBox="1"/>
           <p:nvPr/>
         </p:nvSpPr>
         <p:spPr>
           <a:xfrm>
-            <a:off x="713232" y="3886200"/>
-            <a:ext cx="1792224" cy="1097280"/>
+            <a:off x="822960" y="3749040"/>
+            <a:ext cx="1572768" cy="329184"/>
+          </a:xfrm>
+          <a:prstGeom prst="rect">
+            <a:avLst/>
+          </a:prstGeom>
+          <a:noFill/>
+          <a:ln/>
+        </p:spPr>
+        <p:txBody>
+          <a:bodyPr wrap="square" lIns="0" tIns="0" rIns="0" bIns="0" rtlCol="0" anchor="ctr"/>
+          <a:lstStyle/>
+          <a:p>
+            <a:pPr algn="ctr" indent="0" marL="0">
+              <a:buNone/>
+            </a:pPr>
+            <a:r>
+              <a:rPr lang="en-US" sz="1150" b="1" dirty="0">
+                <a:solidFill>
+                  <a:schemeClr val="accent1"/>
+                </a:solidFill>
+              </a:rPr>
+              <a:t>Admin</a:t>
+            </a:r>
+            <a:endParaRPr lang="en-US" sz="1150" dirty="0"/>
+          </a:p>
+        </p:txBody>
+      </p:sp>
+      <p:sp>
+        <p:nvSpPr>
+          <p:cNvPr id="10" name="a-up-w-tmf0"/>
+          <p:cNvSpPr txBox="1"/>
+          <p:nvPr/>
+        </p:nvSpPr>
+        <p:spPr>
+          <a:xfrm>
+            <a:off x="713232" y="4187952"/>
+            <a:ext cx="1792224" cy="822960"/>
           </a:xfrm>
           <a:prstGeom prst="rect">
             <a:avLst/>
@@ -19678,20 +19741,20 @@
               <a:buNone/>
             </a:pPr>
             <a:r>
-              <a:rPr lang="en-US" sz="1150" dirty="0">
+              <a:rPr lang="en-US" sz="1050" dirty="0">
                 <a:solidFill>
                   <a:schemeClr val="accent6"/>
                 </a:solidFill>
               </a:rPr>
               <a:t>Requirement analysis, admin module and project coordination</a:t>
             </a:r>
-            <a:endParaRPr lang="en-US" sz="1150" dirty="0"/>
+            <a:endParaRPr lang="en-US" sz="1050" dirty="0"/>
           </a:p>
         </p:txBody>
       </p:sp>
       <p:sp>
         <p:nvSpPr>
-          <p:cNvPr id="9" name="a-up-w-tmp0"/>
+          <p:cNvPr id="11" name="a-up-w-tmp0"/>
           <p:cNvSpPr txBox="1"/>
           <p:nvPr/>
         </p:nvSpPr>
@@ -19727,7 +19790,7 @@
       </p:sp>
       <p:sp>
         <p:nvSpPr>
-          <p:cNvPr id="10" name="a-up-tm1"/>
+          <p:cNvPr id="12" name="a-up-tm1"/>
           <p:cNvSpPr/>
           <p:nvPr/>
         </p:nvSpPr>
@@ -19761,7 +19824,7 @@
       </p:sp>
       <p:sp>
         <p:nvSpPr>
-          <p:cNvPr id="11" name="a-up-w-tmc1"/>
+          <p:cNvPr id="13" name="a-up-w-tmc1"/>
           <p:cNvSpPr/>
           <p:nvPr/>
         </p:nvSpPr>
@@ -19781,7 +19844,7 @@
       </p:sp>
       <p:sp>
         <p:nvSpPr>
-          <p:cNvPr id="12" name="a-up-w-tmi1"/>
+          <p:cNvPr id="14" name="a-up-w-tmi1"/>
           <p:cNvSpPr txBox="1"/>
           <p:nvPr/>
         </p:nvSpPr>
@@ -19817,14 +19880,14 @@
       </p:sp>
       <p:sp>
         <p:nvSpPr>
-          <p:cNvPr id="13" name="a-up-w-tmn1"/>
+          <p:cNvPr id="15" name="a-up-w-tmn1"/>
           <p:cNvSpPr txBox="1"/>
           <p:nvPr/>
         </p:nvSpPr>
         <p:spPr>
           <a:xfrm>
-            <a:off x="2916936" y="2788920"/>
-            <a:ext cx="1847088" cy="685800"/>
+            <a:off x="2871216" y="2743200"/>
+            <a:ext cx="1938528" cy="640080"/>
           </a:xfrm>
           <a:prstGeom prst="rect">
             <a:avLst/>
@@ -19853,14 +19916,14 @@
       </p:sp>
       <p:sp>
         <p:nvSpPr>
-          <p:cNvPr id="14" name="a-up-w-tmd1"/>
+          <p:cNvPr id="16" name="a-up-w-tmd1"/>
           <p:cNvSpPr txBox="1"/>
           <p:nvPr/>
         </p:nvSpPr>
         <p:spPr>
           <a:xfrm>
-            <a:off x="2916936" y="3474720"/>
-            <a:ext cx="1847088" cy="274320"/>
+            <a:off x="2916936" y="3429000"/>
+            <a:ext cx="1847088" cy="256032"/>
           </a:xfrm>
           <a:prstGeom prst="rect">
             <a:avLst/>
@@ -19889,14 +19952,77 @@
       </p:sp>
       <p:sp>
         <p:nvSpPr>
-          <p:cNvPr id="15" name="a-up-w-tmf1"/>
+          <p:cNvPr id="17" name="a-up-w-tmr1"/>
+          <p:cNvSpPr/>
+          <p:nvPr/>
+        </p:nvSpPr>
+        <p:spPr>
+          <a:xfrm>
+            <a:off x="3054096" y="3749040"/>
+            <a:ext cx="1572768" cy="329184"/>
+          </a:xfrm>
+          <a:prstGeom prst="roundRect">
+            <a:avLst>
+              <a:gd name="adj" fmla="val 50000"/>
+            </a:avLst>
+          </a:prstGeom>
+          <a:solidFill>
+            <a:schemeClr val="bg2"/>
+          </a:solidFill>
+          <a:ln w="6350">
+            <a:solidFill>
+              <a:srgbClr val="CBD5E1"/>
+            </a:solidFill>
+            <a:prstDash val="solid"/>
+          </a:ln>
+        </p:spPr>
+      </p:sp>
+      <p:sp>
+        <p:nvSpPr>
+          <p:cNvPr id="18" name="a-up-w-tmrt1"/>
           <p:cNvSpPr txBox="1"/>
           <p:nvPr/>
         </p:nvSpPr>
         <p:spPr>
           <a:xfrm>
-            <a:off x="2944368" y="3886200"/>
-            <a:ext cx="1792224" cy="1097280"/>
+            <a:off x="3054096" y="3749040"/>
+            <a:ext cx="1572768" cy="329184"/>
+          </a:xfrm>
+          <a:prstGeom prst="rect">
+            <a:avLst/>
+          </a:prstGeom>
+          <a:noFill/>
+          <a:ln/>
+        </p:spPr>
+        <p:txBody>
+          <a:bodyPr wrap="square" lIns="0" tIns="0" rIns="0" bIns="0" rtlCol="0" anchor="ctr"/>
+          <a:lstStyle/>
+          <a:p>
+            <a:pPr algn="ctr" indent="0" marL="0">
+              <a:buNone/>
+            </a:pPr>
+            <a:r>
+              <a:rPr lang="en-US" sz="1150" b="1" dirty="0">
+                <a:solidFill>
+                  <a:schemeClr val="accent1"/>
+                </a:solidFill>
+              </a:rPr>
+              <a:t>Retail Staff</a:t>
+            </a:r>
+            <a:endParaRPr lang="en-US" sz="1150" dirty="0"/>
+          </a:p>
+        </p:txBody>
+      </p:sp>
+      <p:sp>
+        <p:nvSpPr>
+          <p:cNvPr id="19" name="a-up-w-tmf1"/>
+          <p:cNvSpPr txBox="1"/>
+          <p:nvPr/>
+        </p:nvSpPr>
+        <p:spPr>
+          <a:xfrm>
+            <a:off x="2944368" y="4187952"/>
+            <a:ext cx="1792224" cy="822960"/>
           </a:xfrm>
           <a:prstGeom prst="rect">
             <a:avLst/>
@@ -19912,20 +20038,20 @@
               <a:buNone/>
             </a:pPr>
             <a:r>
-              <a:rPr lang="en-US" sz="1150" dirty="0">
+              <a:rPr lang="en-US" sz="1050" dirty="0">
                 <a:solidFill>
                   <a:schemeClr val="accent6"/>
                 </a:solidFill>
               </a:rPr>
               <a:t>Database design, ER diagram, entities and migrations</a:t>
             </a:r>
-            <a:endParaRPr lang="en-US" sz="1150" dirty="0"/>
+            <a:endParaRPr lang="en-US" sz="1050" dirty="0"/>
           </a:p>
         </p:txBody>
       </p:sp>
       <p:sp>
         <p:nvSpPr>
-          <p:cNvPr id="16" name="a-up-w-tmp1"/>
+          <p:cNvPr id="20" name="a-up-w-tmp1"/>
           <p:cNvSpPr txBox="1"/>
           <p:nvPr/>
         </p:nvSpPr>
@@ -19961,7 +20087,7 @@
       </p:sp>
       <p:sp>
         <p:nvSpPr>
-          <p:cNvPr id="17" name="a-up-tm2"/>
+          <p:cNvPr id="21" name="a-up-tm2"/>
           <p:cNvSpPr/>
           <p:nvPr/>
         </p:nvSpPr>
@@ -19995,7 +20121,7 @@
       </p:sp>
       <p:sp>
         <p:nvSpPr>
-          <p:cNvPr id="18" name="a-up-w-tmc2"/>
+          <p:cNvPr id="22" name="a-up-w-tmc2"/>
           <p:cNvSpPr/>
           <p:nvPr/>
         </p:nvSpPr>
@@ -20015,7 +20141,7 @@
       </p:sp>
       <p:sp>
         <p:nvSpPr>
-          <p:cNvPr id="19" name="a-up-w-tmi2"/>
+          <p:cNvPr id="23" name="a-up-w-tmi2"/>
           <p:cNvSpPr txBox="1"/>
           <p:nvPr/>
         </p:nvSpPr>
@@ -20051,14 +20177,14 @@
       </p:sp>
       <p:sp>
         <p:nvSpPr>
-          <p:cNvPr id="20" name="a-up-w-tmn2"/>
+          <p:cNvPr id="24" name="a-up-w-tmn2"/>
           <p:cNvSpPr txBox="1"/>
           <p:nvPr/>
         </p:nvSpPr>
         <p:spPr>
           <a:xfrm>
-            <a:off x="5148072" y="2788920"/>
-            <a:ext cx="1847088" cy="685800"/>
+            <a:off x="5102352" y="2743200"/>
+            <a:ext cx="1938528" cy="640080"/>
           </a:xfrm>
           <a:prstGeom prst="rect">
             <a:avLst/>
@@ -20074,27 +20200,27 @@
               <a:buNone/>
             </a:pPr>
             <a:r>
-              <a:rPr lang="en-US" sz="1500" b="1" dirty="0">
+              <a:rPr lang="en-US" sz="1250" b="1" dirty="0">
                 <a:solidFill>
                   <a:schemeClr val="tx2"/>
                 </a:solidFill>
               </a:rPr>
               <a:t>Muhammad Ehtisham Shakeel</a:t>
             </a:r>
-            <a:endParaRPr lang="en-US" sz="1500" dirty="0"/>
+            <a:endParaRPr lang="en-US" sz="1250" dirty="0"/>
           </a:p>
         </p:txBody>
       </p:sp>
       <p:sp>
         <p:nvSpPr>
-          <p:cNvPr id="21" name="a-up-w-tmd2"/>
+          <p:cNvPr id="25" name="a-up-w-tmd2"/>
           <p:cNvSpPr txBox="1"/>
           <p:nvPr/>
         </p:nvSpPr>
         <p:spPr>
           <a:xfrm>
-            <a:off x="5148072" y="3474720"/>
-            <a:ext cx="1847088" cy="274320"/>
+            <a:off x="5148072" y="3429000"/>
+            <a:ext cx="1847088" cy="256032"/>
           </a:xfrm>
           <a:prstGeom prst="rect">
             <a:avLst/>
@@ -20123,14 +20249,77 @@
       </p:sp>
       <p:sp>
         <p:nvSpPr>
-          <p:cNvPr id="22" name="a-up-w-tmf2"/>
+          <p:cNvPr id="26" name="a-up-w-tmr2"/>
+          <p:cNvSpPr/>
+          <p:nvPr/>
+        </p:nvSpPr>
+        <p:spPr>
+          <a:xfrm>
+            <a:off x="5285232" y="3749040"/>
+            <a:ext cx="1572768" cy="329184"/>
+          </a:xfrm>
+          <a:prstGeom prst="roundRect">
+            <a:avLst>
+              <a:gd name="adj" fmla="val 50000"/>
+            </a:avLst>
+          </a:prstGeom>
+          <a:solidFill>
+            <a:schemeClr val="bg2"/>
+          </a:solidFill>
+          <a:ln w="6350">
+            <a:solidFill>
+              <a:srgbClr val="CBD5E1"/>
+            </a:solidFill>
+            <a:prstDash val="solid"/>
+          </a:ln>
+        </p:spPr>
+      </p:sp>
+      <p:sp>
+        <p:nvSpPr>
+          <p:cNvPr id="27" name="a-up-w-tmrt2"/>
           <p:cNvSpPr txBox="1"/>
           <p:nvPr/>
         </p:nvSpPr>
         <p:spPr>
           <a:xfrm>
-            <a:off x="5175504" y="3886200"/>
-            <a:ext cx="1792224" cy="1097280"/>
+            <a:off x="5285232" y="3749040"/>
+            <a:ext cx="1572768" cy="329184"/>
+          </a:xfrm>
+          <a:prstGeom prst="rect">
+            <a:avLst/>
+          </a:prstGeom>
+          <a:noFill/>
+          <a:ln/>
+        </p:spPr>
+        <p:txBody>
+          <a:bodyPr wrap="square" lIns="0" tIns="0" rIns="0" bIns="0" rtlCol="0" anchor="ctr"/>
+          <a:lstStyle/>
+          <a:p>
+            <a:pPr algn="ctr" indent="0" marL="0">
+              <a:buNone/>
+            </a:pPr>
+            <a:r>
+              <a:rPr lang="en-US" sz="1150" b="1" dirty="0">
+                <a:solidFill>
+                  <a:schemeClr val="accent1"/>
+                </a:solidFill>
+              </a:rPr>
+              <a:t>Technical Staff</a:t>
+            </a:r>
+            <a:endParaRPr lang="en-US" sz="1150" dirty="0"/>
+          </a:p>
+        </p:txBody>
+      </p:sp>
+      <p:sp>
+        <p:nvSpPr>
+          <p:cNvPr id="28" name="a-up-w-tmf2"/>
+          <p:cNvSpPr txBox="1"/>
+          <p:nvPr/>
+        </p:nvSpPr>
+        <p:spPr>
+          <a:xfrm>
+            <a:off x="5175504" y="4187952"/>
+            <a:ext cx="1792224" cy="822960"/>
           </a:xfrm>
           <a:prstGeom prst="rect">
             <a:avLst/>
@@ -20146,20 +20335,20 @@
               <a:buNone/>
             </a:pPr>
             <a:r>
-              <a:rPr lang="en-US" sz="1150" dirty="0">
+              <a:rPr lang="en-US" sz="1050" dirty="0">
                 <a:solidFill>
                   <a:schemeClr val="accent6"/>
                 </a:solidFill>
               </a:rPr>
               <a:t>Login and security, orders, feasibility and connections</a:t>
             </a:r>
-            <a:endParaRPr lang="en-US" sz="1150" dirty="0"/>
+            <a:endParaRPr lang="en-US" sz="1050" dirty="0"/>
           </a:p>
         </p:txBody>
       </p:sp>
       <p:sp>
         <p:nvSpPr>
-          <p:cNvPr id="23" name="a-up-w-tmp2"/>
+          <p:cNvPr id="29" name="a-up-w-tmp2"/>
           <p:cNvSpPr txBox="1"/>
           <p:nvPr/>
         </p:nvSpPr>
@@ -20195,7 +20384,7 @@
       </p:sp>
       <p:sp>
         <p:nvSpPr>
-          <p:cNvPr id="24" name="a-up-tm3"/>
+          <p:cNvPr id="30" name="a-up-tm3"/>
           <p:cNvSpPr/>
           <p:nvPr/>
         </p:nvSpPr>
@@ -20229,7 +20418,7 @@
       </p:sp>
       <p:sp>
         <p:nvSpPr>
-          <p:cNvPr id="25" name="a-up-w-tmc3"/>
+          <p:cNvPr id="31" name="a-up-w-tmc3"/>
           <p:cNvSpPr/>
           <p:nvPr/>
         </p:nvSpPr>
@@ -20249,7 +20438,7 @@
       </p:sp>
       <p:sp>
         <p:nvSpPr>
-          <p:cNvPr id="26" name="a-up-w-tmi3"/>
+          <p:cNvPr id="32" name="a-up-w-tmi3"/>
           <p:cNvSpPr txBox="1"/>
           <p:nvPr/>
         </p:nvSpPr>
@@ -20285,14 +20474,14 @@
       </p:sp>
       <p:sp>
         <p:nvSpPr>
-          <p:cNvPr id="27" name="a-up-w-tmn3"/>
+          <p:cNvPr id="33" name="a-up-w-tmn3"/>
           <p:cNvSpPr txBox="1"/>
           <p:nvPr/>
         </p:nvSpPr>
         <p:spPr>
           <a:xfrm>
-            <a:off x="7379208" y="2788920"/>
-            <a:ext cx="1847088" cy="685800"/>
+            <a:off x="7333488" y="2743200"/>
+            <a:ext cx="1938528" cy="640080"/>
           </a:xfrm>
           <a:prstGeom prst="rect">
             <a:avLst/>
@@ -20308,27 +20497,27 @@
               <a:buNone/>
             </a:pPr>
             <a:r>
-              <a:rPr lang="en-US" sz="1500" b="1" dirty="0">
+              <a:rPr lang="en-US" sz="1250" b="1" dirty="0">
                 <a:solidFill>
                   <a:schemeClr val="tx2"/>
                 </a:solidFill>
               </a:rPr>
               <a:t>Muhammad Waleed</a:t>
             </a:r>
-            <a:endParaRPr lang="en-US" sz="1500" dirty="0"/>
+            <a:endParaRPr lang="en-US" sz="1250" dirty="0"/>
           </a:p>
         </p:txBody>
       </p:sp>
       <p:sp>
         <p:nvSpPr>
-          <p:cNvPr id="28" name="a-up-w-tmd3"/>
+          <p:cNvPr id="34" name="a-up-w-tmd3"/>
           <p:cNvSpPr txBox="1"/>
           <p:nvPr/>
         </p:nvSpPr>
         <p:spPr>
           <a:xfrm>
-            <a:off x="7379208" y="3474720"/>
-            <a:ext cx="1847088" cy="274320"/>
+            <a:off x="7379208" y="3429000"/>
+            <a:ext cx="1847088" cy="256032"/>
           </a:xfrm>
           <a:prstGeom prst="rect">
             <a:avLst/>
@@ -20357,14 +20546,77 @@
       </p:sp>
       <p:sp>
         <p:nvSpPr>
-          <p:cNvPr id="29" name="a-up-w-tmf3"/>
+          <p:cNvPr id="35" name="a-up-w-tmr3"/>
+          <p:cNvSpPr/>
+          <p:nvPr/>
+        </p:nvSpPr>
+        <p:spPr>
+          <a:xfrm>
+            <a:off x="7516368" y="3749040"/>
+            <a:ext cx="1572768" cy="329184"/>
+          </a:xfrm>
+          <a:prstGeom prst="roundRect">
+            <a:avLst>
+              <a:gd name="adj" fmla="val 50000"/>
+            </a:avLst>
+          </a:prstGeom>
+          <a:solidFill>
+            <a:schemeClr val="bg2"/>
+          </a:solidFill>
+          <a:ln w="6350">
+            <a:solidFill>
+              <a:srgbClr val="CBD5E1"/>
+            </a:solidFill>
+            <a:prstDash val="solid"/>
+          </a:ln>
+        </p:spPr>
+      </p:sp>
+      <p:sp>
+        <p:nvSpPr>
+          <p:cNvPr id="36" name="a-up-w-tmrt3"/>
           <p:cNvSpPr txBox="1"/>
           <p:nvPr/>
         </p:nvSpPr>
         <p:spPr>
           <a:xfrm>
-            <a:off x="7406640" y="3886200"/>
-            <a:ext cx="1792224" cy="1097280"/>
+            <a:off x="7516368" y="3749040"/>
+            <a:ext cx="1572768" cy="329184"/>
+          </a:xfrm>
+          <a:prstGeom prst="rect">
+            <a:avLst/>
+          </a:prstGeom>
+          <a:noFill/>
+          <a:ln/>
+        </p:spPr>
+        <p:txBody>
+          <a:bodyPr wrap="square" lIns="0" tIns="0" rIns="0" bIns="0" rtlCol="0" anchor="ctr"/>
+          <a:lstStyle/>
+          <a:p>
+            <a:pPr algn="ctr" indent="0" marL="0">
+              <a:buNone/>
+            </a:pPr>
+            <a:r>
+              <a:rPr lang="en-US" sz="1150" b="1" dirty="0">
+                <a:solidFill>
+                  <a:schemeClr val="accent1"/>
+                </a:solidFill>
+              </a:rPr>
+              <a:t>Accounts Staff</a:t>
+            </a:r>
+            <a:endParaRPr lang="en-US" sz="1150" dirty="0"/>
+          </a:p>
+        </p:txBody>
+      </p:sp>
+      <p:sp>
+        <p:nvSpPr>
+          <p:cNvPr id="37" name="a-up-w-tmf3"/>
+          <p:cNvSpPr txBox="1"/>
+          <p:nvPr/>
+        </p:nvSpPr>
+        <p:spPr>
+          <a:xfrm>
+            <a:off x="7406640" y="4187952"/>
+            <a:ext cx="1792224" cy="822960"/>
           </a:xfrm>
           <a:prstGeom prst="rect">
             <a:avLst/>
@@ -20380,20 +20632,20 @@
               <a:buNone/>
             </a:pPr>
             <a:r>
-              <a:rPr lang="en-US" sz="1150" dirty="0">
+              <a:rPr lang="en-US" sz="1050" dirty="0">
                 <a:solidFill>
                   <a:schemeClr val="accent6"/>
                 </a:solidFill>
               </a:rPr>
               <a:t>Billing, payments, overdue control, tracking and search</a:t>
             </a:r>
-            <a:endParaRPr lang="en-US" sz="1150" dirty="0"/>
+            <a:endParaRPr lang="en-US" sz="1050" dirty="0"/>
           </a:p>
         </p:txBody>
       </p:sp>
       <p:sp>
         <p:nvSpPr>
-          <p:cNvPr id="30" name="a-up-w-tmp3"/>
+          <p:cNvPr id="38" name="a-up-w-tmp3"/>
           <p:cNvSpPr txBox="1"/>
           <p:nvPr/>
         </p:nvSpPr>
@@ -20429,7 +20681,7 @@
       </p:sp>
       <p:sp>
         <p:nvSpPr>
-          <p:cNvPr id="31" name="a-up-tm4"/>
+          <p:cNvPr id="39" name="a-up-tm4"/>
           <p:cNvSpPr/>
           <p:nvPr/>
         </p:nvSpPr>
@@ -20463,7 +20715,7 @@
       </p:sp>
       <p:sp>
         <p:nvSpPr>
-          <p:cNvPr id="32" name="a-up-w-tmc4"/>
+          <p:cNvPr id="40" name="a-up-w-tmc4"/>
           <p:cNvSpPr/>
           <p:nvPr/>
         </p:nvSpPr>
@@ -20483,7 +20735,7 @@
       </p:sp>
       <p:sp>
         <p:nvSpPr>
-          <p:cNvPr id="33" name="a-up-w-tmi4"/>
+          <p:cNvPr id="41" name="a-up-w-tmi4"/>
           <p:cNvSpPr txBox="1"/>
           <p:nvPr/>
         </p:nvSpPr>
@@ -20519,14 +20771,14 @@
       </p:sp>
       <p:sp>
         <p:nvSpPr>
-          <p:cNvPr id="34" name="a-up-w-tmn4"/>
+          <p:cNvPr id="42" name="a-up-w-tmn4"/>
           <p:cNvSpPr txBox="1"/>
           <p:nvPr/>
         </p:nvSpPr>
         <p:spPr>
           <a:xfrm>
-            <a:off x="9610344" y="2788920"/>
-            <a:ext cx="1847088" cy="685800"/>
+            <a:off x="9564624" y="2743200"/>
+            <a:ext cx="1938528" cy="640080"/>
           </a:xfrm>
           <a:prstGeom prst="rect">
             <a:avLst/>
@@ -20555,14 +20807,14 @@
       </p:sp>
       <p:sp>
         <p:nvSpPr>
-          <p:cNvPr id="35" name="a-up-w-tmd4"/>
+          <p:cNvPr id="43" name="a-up-w-tmd4"/>
           <p:cNvSpPr txBox="1"/>
           <p:nvPr/>
         </p:nvSpPr>
         <p:spPr>
           <a:xfrm>
-            <a:off x="9610344" y="3474720"/>
-            <a:ext cx="1847088" cy="274320"/>
+            <a:off x="9610344" y="3429000"/>
+            <a:ext cx="1847088" cy="256032"/>
           </a:xfrm>
           <a:prstGeom prst="rect">
             <a:avLst/>
@@ -20591,14 +20843,77 @@
       </p:sp>
       <p:sp>
         <p:nvSpPr>
-          <p:cNvPr id="36" name="a-up-w-tmf4"/>
+          <p:cNvPr id="44" name="a-up-w-tmr4"/>
+          <p:cNvSpPr/>
+          <p:nvPr/>
+        </p:nvSpPr>
+        <p:spPr>
+          <a:xfrm>
+            <a:off x="9747504" y="3749040"/>
+            <a:ext cx="1572768" cy="329184"/>
+          </a:xfrm>
+          <a:prstGeom prst="roundRect">
+            <a:avLst>
+              <a:gd name="adj" fmla="val 50000"/>
+            </a:avLst>
+          </a:prstGeom>
+          <a:solidFill>
+            <a:schemeClr val="bg2"/>
+          </a:solidFill>
+          <a:ln w="6350">
+            <a:solidFill>
+              <a:srgbClr val="CBD5E1"/>
+            </a:solidFill>
+            <a:prstDash val="solid"/>
+          </a:ln>
+        </p:spPr>
+      </p:sp>
+      <p:sp>
+        <p:nvSpPr>
+          <p:cNvPr id="45" name="a-up-w-tmrt4"/>
           <p:cNvSpPr txBox="1"/>
           <p:nvPr/>
         </p:nvSpPr>
         <p:spPr>
           <a:xfrm>
-            <a:off x="9637776" y="3886200"/>
-            <a:ext cx="1792224" cy="1097280"/>
+            <a:off x="9747504" y="3749040"/>
+            <a:ext cx="1572768" cy="329184"/>
+          </a:xfrm>
+          <a:prstGeom prst="rect">
+            <a:avLst/>
+          </a:prstGeom>
+          <a:noFill/>
+          <a:ln/>
+        </p:spPr>
+        <p:txBody>
+          <a:bodyPr wrap="square" lIns="0" tIns="0" rIns="0" bIns="0" rtlCol="0" anchor="ctr"/>
+          <a:lstStyle/>
+          <a:p>
+            <a:pPr algn="ctr" indent="0" marL="0">
+              <a:buNone/>
+            </a:pPr>
+            <a:r>
+              <a:rPr lang="en-US" sz="1150" b="1" dirty="0">
+                <a:solidFill>
+                  <a:schemeClr val="accent1"/>
+                </a:solidFill>
+              </a:rPr>
+              <a:t>Customer</a:t>
+            </a:r>
+            <a:endParaRPr lang="en-US" sz="1150" dirty="0"/>
+          </a:p>
+        </p:txBody>
+      </p:sp>
+      <p:sp>
+        <p:nvSpPr>
+          <p:cNvPr id="46" name="a-up-w-tmf4"/>
+          <p:cNvSpPr txBox="1"/>
+          <p:nvPr/>
+        </p:nvSpPr>
+        <p:spPr>
+          <a:xfrm>
+            <a:off x="9637776" y="4187952"/>
+            <a:ext cx="1792224" cy="822960"/>
           </a:xfrm>
           <a:prstGeom prst="rect">
             <a:avLst/>
@@ -20614,20 +20929,20 @@
               <a:buNone/>
             </a:pPr>
             <a:r>
-              <a:rPr lang="en-US" sz="1150" dirty="0">
+              <a:rPr lang="en-US" sz="1050" dirty="0">
                 <a:solidFill>
                   <a:schemeClr val="accent6"/>
                 </a:solidFill>
               </a:rPr>
               <a:t>Interface design, customer documents, testing and documentation</a:t>
             </a:r>
-            <a:endParaRPr lang="en-US" sz="1150" dirty="0"/>
+            <a:endParaRPr lang="en-US" sz="1050" dirty="0"/>
           </a:p>
         </p:txBody>
       </p:sp>
       <p:sp>
         <p:nvSpPr>
-          <p:cNvPr id="37" name="a-up-w-tmp4"/>
+          <p:cNvPr id="47" name="a-up-w-tmp4"/>
           <p:cNvSpPr txBox="1"/>
           <p:nvPr/>
         </p:nvSpPr>
@@ -20658,6 +20973,42 @@
               <a:t>Slides 13-17: interface, quality and closing</a:t>
             </a:r>
             <a:endParaRPr lang="en-US" sz="1050" dirty="0"/>
+          </a:p>
+        </p:txBody>
+      </p:sp>
+      <p:sp>
+        <p:nvSpPr>
+          <p:cNvPr id="48" name="a-fade-tmfoot"/>
+          <p:cNvSpPr txBox="1"/>
+          <p:nvPr/>
+        </p:nvSpPr>
+        <p:spPr>
+          <a:xfrm>
+            <a:off x="548640" y="5989320"/>
+            <a:ext cx="11064240" cy="274320"/>
+          </a:xfrm>
+          <a:prstGeom prst="rect">
+            <a:avLst/>
+          </a:prstGeom>
+          <a:noFill/>
+          <a:ln/>
+        </p:spPr>
+        <p:txBody>
+          <a:bodyPr wrap="square" lIns="0" tIns="0" rIns="0" bIns="0" rtlCol="0" anchor="t"/>
+          <a:lstStyle/>
+          <a:p>
+            <a:pPr algn="ctr" indent="0" marL="0">
+              <a:buNone/>
+            </a:pPr>
+            <a:r>
+              <a:rPr lang="en-US" sz="1200" dirty="0">
+                <a:solidFill>
+                  <a:schemeClr val="accent6"/>
+                </a:solidFill>
+              </a:rPr>
+              <a:t>ADSE  ·  Semester 3  ·  Aptech Center NN2</a:t>
+            </a:r>
+            <a:endParaRPr lang="en-US" sz="1200" dirty="0"/>
           </a:p>
         </p:txBody>
       </p:sp>
@@ -20732,7 +21083,7 @@
                       </p:stCondLst>
                       <p:childTnLst>
                         <p:par>
-                          <p:cTn id="185" fill="hold">
+                          <p:cTn id="238" fill="hold">
                             <p:stCondLst>
                               <p:cond delay="0"/>
                             </p:stCondLst>
@@ -21342,7 +21693,7 @@
                               <p:par>
                                 <p:cTn id="46" presetID="42" presetClass="entr" presetSubtype="0" fill="hold" grpId="0" nodeType="withEffect">
                                   <p:stCondLst>
-                                    <p:cond delay="400"/>
+                                    <p:cond delay="200"/>
                                   </p:stCondLst>
                                   <p:childTnLst>
                                     <p:set>
@@ -21423,7 +21774,7 @@
                               <p:par>
                                 <p:cTn id="51" presetID="42" presetClass="entr" presetSubtype="0" fill="hold" grpId="0" nodeType="withEffect">
                                   <p:stCondLst>
-                                    <p:cond delay="400"/>
+                                    <p:cond delay="200"/>
                                   </p:stCondLst>
                                   <p:childTnLst>
                                     <p:set>
@@ -21909,7 +22260,7 @@
                               <p:par>
                                 <p:cTn id="81" presetID="42" presetClass="entr" presetSubtype="0" fill="hold" grpId="0" nodeType="withEffect">
                                   <p:stCondLst>
-                                    <p:cond delay="600"/>
+                                    <p:cond delay="400"/>
                                   </p:stCondLst>
                                   <p:childTnLst>
                                     <p:set>
@@ -21990,7 +22341,7 @@
                               <p:par>
                                 <p:cTn id="86" presetID="42" presetClass="entr" presetSubtype="0" fill="hold" grpId="0" nodeType="withEffect">
                                   <p:stCondLst>
-                                    <p:cond delay="600"/>
+                                    <p:cond delay="400"/>
                                   </p:stCondLst>
                                   <p:childTnLst>
                                     <p:set>
@@ -22071,7 +22422,7 @@
                               <p:par>
                                 <p:cTn id="91" presetID="42" presetClass="entr" presetSubtype="0" fill="hold" grpId="0" nodeType="withEffect">
                                   <p:stCondLst>
-                                    <p:cond delay="600"/>
+                                    <p:cond delay="400"/>
                                   </p:stCondLst>
                                   <p:childTnLst>
                                     <p:set>
@@ -22152,7 +22503,7 @@
                               <p:par>
                                 <p:cTn id="96" presetID="42" presetClass="entr" presetSubtype="0" fill="hold" grpId="0" nodeType="withEffect">
                                   <p:stCondLst>
-                                    <p:cond delay="600"/>
+                                    <p:cond delay="400"/>
                                   </p:stCondLst>
                                   <p:childTnLst>
                                     <p:set>
@@ -22476,7 +22827,7 @@
                               <p:par>
                                 <p:cTn id="116" presetID="42" presetClass="entr" presetSubtype="0" fill="hold" grpId="0" nodeType="withEffect">
                                   <p:stCondLst>
-                                    <p:cond delay="800"/>
+                                    <p:cond delay="600"/>
                                   </p:stCondLst>
                                   <p:childTnLst>
                                     <p:set>
@@ -22557,7 +22908,7 @@
                               <p:par>
                                 <p:cTn id="121" presetID="42" presetClass="entr" presetSubtype="0" fill="hold" grpId="0" nodeType="withEffect">
                                   <p:stCondLst>
-                                    <p:cond delay="800"/>
+                                    <p:cond delay="600"/>
                                   </p:stCondLst>
                                   <p:childTnLst>
                                     <p:set>
@@ -22638,7 +22989,7 @@
                               <p:par>
                                 <p:cTn id="126" presetID="42" presetClass="entr" presetSubtype="0" fill="hold" grpId="0" nodeType="withEffect">
                                   <p:stCondLst>
-                                    <p:cond delay="800"/>
+                                    <p:cond delay="600"/>
                                   </p:stCondLst>
                                   <p:childTnLst>
                                     <p:set>
@@ -22719,7 +23070,7 @@
                               <p:par>
                                 <p:cTn id="131" presetID="42" presetClass="entr" presetSubtype="0" fill="hold" grpId="0" nodeType="withEffect">
                                   <p:stCondLst>
-                                    <p:cond delay="800"/>
+                                    <p:cond delay="600"/>
                                   </p:stCondLst>
                                   <p:childTnLst>
                                     <p:set>
@@ -22800,7 +23151,7 @@
                               <p:par>
                                 <p:cTn id="136" presetID="42" presetClass="entr" presetSubtype="0" fill="hold" grpId="0" nodeType="withEffect">
                                   <p:stCondLst>
-                                    <p:cond delay="800"/>
+                                    <p:cond delay="600"/>
                                   </p:stCondLst>
                                   <p:childTnLst>
                                     <p:set>
@@ -22881,7 +23232,7 @@
                               <p:par>
                                 <p:cTn id="141" presetID="42" presetClass="entr" presetSubtype="0" fill="hold" grpId="0" nodeType="withEffect">
                                   <p:stCondLst>
-                                    <p:cond delay="800"/>
+                                    <p:cond delay="600"/>
                                   </p:stCondLst>
                                   <p:childTnLst>
                                     <p:set>
@@ -23043,7 +23394,7 @@
                               <p:par>
                                 <p:cTn id="151" presetID="42" presetClass="entr" presetSubtype="0" fill="hold" grpId="0" nodeType="withEffect">
                                   <p:stCondLst>
-                                    <p:cond delay="1000"/>
+                                    <p:cond delay="800"/>
                                   </p:stCondLst>
                                   <p:childTnLst>
                                     <p:set>
@@ -23124,7 +23475,7 @@
                               <p:par>
                                 <p:cTn id="156" presetID="42" presetClass="entr" presetSubtype="0" fill="hold" grpId="0" nodeType="withEffect">
                                   <p:stCondLst>
-                                    <p:cond delay="1000"/>
+                                    <p:cond delay="800"/>
                                   </p:stCondLst>
                                   <p:childTnLst>
                                     <p:set>
@@ -23205,7 +23556,7 @@
                               <p:par>
                                 <p:cTn id="161" presetID="42" presetClass="entr" presetSubtype="0" fill="hold" grpId="0" nodeType="withEffect">
                                   <p:stCondLst>
-                                    <p:cond delay="1000"/>
+                                    <p:cond delay="800"/>
                                   </p:stCondLst>
                                   <p:childTnLst>
                                     <p:set>
@@ -23286,7 +23637,7 @@
                               <p:par>
                                 <p:cTn id="166" presetID="42" presetClass="entr" presetSubtype="0" fill="hold" grpId="0" nodeType="withEffect">
                                   <p:stCondLst>
-                                    <p:cond delay="1000"/>
+                                    <p:cond delay="800"/>
                                   </p:stCondLst>
                                   <p:childTnLst>
                                     <p:set>
@@ -23367,7 +23718,7 @@
                               <p:par>
                                 <p:cTn id="171" presetID="42" presetClass="entr" presetSubtype="0" fill="hold" grpId="0" nodeType="withEffect">
                                   <p:stCondLst>
-                                    <p:cond delay="1000"/>
+                                    <p:cond delay="800"/>
                                   </p:stCondLst>
                                   <p:childTnLst>
                                     <p:set>
@@ -23448,7 +23799,7 @@
                               <p:par>
                                 <p:cTn id="176" presetID="42" presetClass="entr" presetSubtype="0" fill="hold" grpId="0" nodeType="withEffect">
                                   <p:stCondLst>
-                                    <p:cond delay="1000"/>
+                                    <p:cond delay="800"/>
                                   </p:stCondLst>
                                   <p:childTnLst>
                                     <p:set>
@@ -23529,7 +23880,7 @@
                               <p:par>
                                 <p:cTn id="181" presetID="42" presetClass="entr" presetSubtype="0" fill="hold" grpId="0" nodeType="withEffect">
                                   <p:stCondLst>
-                                    <p:cond delay="1000"/>
+                                    <p:cond delay="800"/>
                                   </p:stCondLst>
                                   <p:childTnLst>
                                     <p:set>
@@ -23608,20 +23959,830 @@
                                 </p:cTn>
                               </p:par>
                               <p:par>
-                                <p:cTn id="184" presetID="10" presetClass="entr" presetSubtype="0" fill="hold" grpId="0" nodeType="withEffect">
+                                <p:cTn id="186" presetID="42" presetClass="entr" presetSubtype="0" fill="hold" grpId="0" nodeType="withEffect">
+                                  <p:stCondLst>
+                                    <p:cond delay="800"/>
+                                  </p:stCondLst>
+                                  <p:childTnLst>
+                                    <p:set>
+                                      <p:cBhvr>
+                                        <p:cTn id="182" dur="1" fill="hold">
+                                          <p:stCondLst>
+                                            <p:cond delay="0"/>
+                                          </p:stCondLst>
+                                        </p:cTn>
+                                        <p:tgtEl>
+                                          <p:spTgt spid="38"/>
+                                        </p:tgtEl>
+                                        <p:attrNameLst>
+                                          <p:attrName>style.visibility</p:attrName>
+                                        </p:attrNameLst>
+                                      </p:cBhvr>
+                                      <p:to>
+                                        <p:strVal val="visible"/>
+                                      </p:to>
+                                    </p:set>
+                                    <p:animEffect transition="in" filter="fade">
+                                      <p:cBhvr>
+                                        <p:cTn id="183" dur="600"/>
+                                        <p:tgtEl>
+                                          <p:spTgt spid="38"/>
+                                        </p:tgtEl>
+                                      </p:cBhvr>
+                                    </p:animEffect>
+                                    <p:anim calcmode="lin" valueType="num">
+                                      <p:cBhvr>
+                                        <p:cTn id="184" dur="600" decel="100000" fill="hold"/>
+                                        <p:tgtEl>
+                                          <p:spTgt spid="38"/>
+                                        </p:tgtEl>
+                                        <p:attrNameLst>
+                                          <p:attrName>ppt_x</p:attrName>
+                                        </p:attrNameLst>
+                                      </p:cBhvr>
+                                      <p:tavLst>
+                                        <p:tav tm="0">
+                                          <p:val>
+                                            <p:strVal val="#ppt_x"/>
+                                          </p:val>
+                                        </p:tav>
+                                        <p:tav tm="100000">
+                                          <p:val>
+                                            <p:strVal val="#ppt_x"/>
+                                          </p:val>
+                                        </p:tav>
+                                      </p:tavLst>
+                                    </p:anim>
+                                    <p:anim calcmode="lin" valueType="num">
+                                      <p:cBhvr>
+                                        <p:cTn id="185" dur="600" decel="100000" fill="hold"/>
+                                        <p:tgtEl>
+                                          <p:spTgt spid="38"/>
+                                        </p:tgtEl>
+                                        <p:attrNameLst>
+                                          <p:attrName>ppt_y</p:attrName>
+                                        </p:attrNameLst>
+                                      </p:cBhvr>
+                                      <p:tavLst>
+                                        <p:tav tm="0">
+                                          <p:val>
+                                            <p:strVal val="#ppt_y+.08"/>
+                                          </p:val>
+                                        </p:tav>
+                                        <p:tav tm="100000">
+                                          <p:val>
+                                            <p:strVal val="#ppt_y"/>
+                                          </p:val>
+                                        </p:tav>
+                                      </p:tavLst>
+                                    </p:anim>
+                                  </p:childTnLst>
+                                </p:cTn>
+                              </p:par>
+                              <p:par>
+                                <p:cTn id="191" presetID="42" presetClass="entr" presetSubtype="0" fill="hold" grpId="0" nodeType="withEffect">
+                                  <p:stCondLst>
+                                    <p:cond delay="1000"/>
+                                  </p:stCondLst>
+                                  <p:childTnLst>
+                                    <p:set>
+                                      <p:cBhvr>
+                                        <p:cTn id="187" dur="1" fill="hold">
+                                          <p:stCondLst>
+                                            <p:cond delay="0"/>
+                                          </p:stCondLst>
+                                        </p:cTn>
+                                        <p:tgtEl>
+                                          <p:spTgt spid="39"/>
+                                        </p:tgtEl>
+                                        <p:attrNameLst>
+                                          <p:attrName>style.visibility</p:attrName>
+                                        </p:attrNameLst>
+                                      </p:cBhvr>
+                                      <p:to>
+                                        <p:strVal val="visible"/>
+                                      </p:to>
+                                    </p:set>
+                                    <p:animEffect transition="in" filter="fade">
+                                      <p:cBhvr>
+                                        <p:cTn id="188" dur="600"/>
+                                        <p:tgtEl>
+                                          <p:spTgt spid="39"/>
+                                        </p:tgtEl>
+                                      </p:cBhvr>
+                                    </p:animEffect>
+                                    <p:anim calcmode="lin" valueType="num">
+                                      <p:cBhvr>
+                                        <p:cTn id="189" dur="600" decel="100000" fill="hold"/>
+                                        <p:tgtEl>
+                                          <p:spTgt spid="39"/>
+                                        </p:tgtEl>
+                                        <p:attrNameLst>
+                                          <p:attrName>ppt_x</p:attrName>
+                                        </p:attrNameLst>
+                                      </p:cBhvr>
+                                      <p:tavLst>
+                                        <p:tav tm="0">
+                                          <p:val>
+                                            <p:strVal val="#ppt_x"/>
+                                          </p:val>
+                                        </p:tav>
+                                        <p:tav tm="100000">
+                                          <p:val>
+                                            <p:strVal val="#ppt_x"/>
+                                          </p:val>
+                                        </p:tav>
+                                      </p:tavLst>
+                                    </p:anim>
+                                    <p:anim calcmode="lin" valueType="num">
+                                      <p:cBhvr>
+                                        <p:cTn id="190" dur="600" decel="100000" fill="hold"/>
+                                        <p:tgtEl>
+                                          <p:spTgt spid="39"/>
+                                        </p:tgtEl>
+                                        <p:attrNameLst>
+                                          <p:attrName>ppt_y</p:attrName>
+                                        </p:attrNameLst>
+                                      </p:cBhvr>
+                                      <p:tavLst>
+                                        <p:tav tm="0">
+                                          <p:val>
+                                            <p:strVal val="#ppt_y+.08"/>
+                                          </p:val>
+                                        </p:tav>
+                                        <p:tav tm="100000">
+                                          <p:val>
+                                            <p:strVal val="#ppt_y"/>
+                                          </p:val>
+                                        </p:tav>
+                                      </p:tavLst>
+                                    </p:anim>
+                                  </p:childTnLst>
+                                </p:cTn>
+                              </p:par>
+                              <p:par>
+                                <p:cTn id="196" presetID="42" presetClass="entr" presetSubtype="0" fill="hold" grpId="0" nodeType="withEffect">
+                                  <p:stCondLst>
+                                    <p:cond delay="1000"/>
+                                  </p:stCondLst>
+                                  <p:childTnLst>
+                                    <p:set>
+                                      <p:cBhvr>
+                                        <p:cTn id="192" dur="1" fill="hold">
+                                          <p:stCondLst>
+                                            <p:cond delay="0"/>
+                                          </p:stCondLst>
+                                        </p:cTn>
+                                        <p:tgtEl>
+                                          <p:spTgt spid="40"/>
+                                        </p:tgtEl>
+                                        <p:attrNameLst>
+                                          <p:attrName>style.visibility</p:attrName>
+                                        </p:attrNameLst>
+                                      </p:cBhvr>
+                                      <p:to>
+                                        <p:strVal val="visible"/>
+                                      </p:to>
+                                    </p:set>
+                                    <p:animEffect transition="in" filter="fade">
+                                      <p:cBhvr>
+                                        <p:cTn id="193" dur="600"/>
+                                        <p:tgtEl>
+                                          <p:spTgt spid="40"/>
+                                        </p:tgtEl>
+                                      </p:cBhvr>
+                                    </p:animEffect>
+                                    <p:anim calcmode="lin" valueType="num">
+                                      <p:cBhvr>
+                                        <p:cTn id="194" dur="600" decel="100000" fill="hold"/>
+                                        <p:tgtEl>
+                                          <p:spTgt spid="40"/>
+                                        </p:tgtEl>
+                                        <p:attrNameLst>
+                                          <p:attrName>ppt_x</p:attrName>
+                                        </p:attrNameLst>
+                                      </p:cBhvr>
+                                      <p:tavLst>
+                                        <p:tav tm="0">
+                                          <p:val>
+                                            <p:strVal val="#ppt_x"/>
+                                          </p:val>
+                                        </p:tav>
+                                        <p:tav tm="100000">
+                                          <p:val>
+                                            <p:strVal val="#ppt_x"/>
+                                          </p:val>
+                                        </p:tav>
+                                      </p:tavLst>
+                                    </p:anim>
+                                    <p:anim calcmode="lin" valueType="num">
+                                      <p:cBhvr>
+                                        <p:cTn id="195" dur="600" decel="100000" fill="hold"/>
+                                        <p:tgtEl>
+                                          <p:spTgt spid="40"/>
+                                        </p:tgtEl>
+                                        <p:attrNameLst>
+                                          <p:attrName>ppt_y</p:attrName>
+                                        </p:attrNameLst>
+                                      </p:cBhvr>
+                                      <p:tavLst>
+                                        <p:tav tm="0">
+                                          <p:val>
+                                            <p:strVal val="#ppt_y+.08"/>
+                                          </p:val>
+                                        </p:tav>
+                                        <p:tav tm="100000">
+                                          <p:val>
+                                            <p:strVal val="#ppt_y"/>
+                                          </p:val>
+                                        </p:tav>
+                                      </p:tavLst>
+                                    </p:anim>
+                                  </p:childTnLst>
+                                </p:cTn>
+                              </p:par>
+                              <p:par>
+                                <p:cTn id="201" presetID="42" presetClass="entr" presetSubtype="0" fill="hold" grpId="0" nodeType="withEffect">
+                                  <p:stCondLst>
+                                    <p:cond delay="1000"/>
+                                  </p:stCondLst>
+                                  <p:childTnLst>
+                                    <p:set>
+                                      <p:cBhvr>
+                                        <p:cTn id="197" dur="1" fill="hold">
+                                          <p:stCondLst>
+                                            <p:cond delay="0"/>
+                                          </p:stCondLst>
+                                        </p:cTn>
+                                        <p:tgtEl>
+                                          <p:spTgt spid="41"/>
+                                        </p:tgtEl>
+                                        <p:attrNameLst>
+                                          <p:attrName>style.visibility</p:attrName>
+                                        </p:attrNameLst>
+                                      </p:cBhvr>
+                                      <p:to>
+                                        <p:strVal val="visible"/>
+                                      </p:to>
+                                    </p:set>
+                                    <p:animEffect transition="in" filter="fade">
+                                      <p:cBhvr>
+                                        <p:cTn id="198" dur="600"/>
+                                        <p:tgtEl>
+                                          <p:spTgt spid="41"/>
+                                        </p:tgtEl>
+                                      </p:cBhvr>
+                                    </p:animEffect>
+                                    <p:anim calcmode="lin" valueType="num">
+                                      <p:cBhvr>
+                                        <p:cTn id="199" dur="600" decel="100000" fill="hold"/>
+                                        <p:tgtEl>
+                                          <p:spTgt spid="41"/>
+                                        </p:tgtEl>
+                                        <p:attrNameLst>
+                                          <p:attrName>ppt_x</p:attrName>
+                                        </p:attrNameLst>
+                                      </p:cBhvr>
+                                      <p:tavLst>
+                                        <p:tav tm="0">
+                                          <p:val>
+                                            <p:strVal val="#ppt_x"/>
+                                          </p:val>
+                                        </p:tav>
+                                        <p:tav tm="100000">
+                                          <p:val>
+                                            <p:strVal val="#ppt_x"/>
+                                          </p:val>
+                                        </p:tav>
+                                      </p:tavLst>
+                                    </p:anim>
+                                    <p:anim calcmode="lin" valueType="num">
+                                      <p:cBhvr>
+                                        <p:cTn id="200" dur="600" decel="100000" fill="hold"/>
+                                        <p:tgtEl>
+                                          <p:spTgt spid="41"/>
+                                        </p:tgtEl>
+                                        <p:attrNameLst>
+                                          <p:attrName>ppt_y</p:attrName>
+                                        </p:attrNameLst>
+                                      </p:cBhvr>
+                                      <p:tavLst>
+                                        <p:tav tm="0">
+                                          <p:val>
+                                            <p:strVal val="#ppt_y+.08"/>
+                                          </p:val>
+                                        </p:tav>
+                                        <p:tav tm="100000">
+                                          <p:val>
+                                            <p:strVal val="#ppt_y"/>
+                                          </p:val>
+                                        </p:tav>
+                                      </p:tavLst>
+                                    </p:anim>
+                                  </p:childTnLst>
+                                </p:cTn>
+                              </p:par>
+                              <p:par>
+                                <p:cTn id="206" presetID="42" presetClass="entr" presetSubtype="0" fill="hold" grpId="0" nodeType="withEffect">
+                                  <p:stCondLst>
+                                    <p:cond delay="1000"/>
+                                  </p:stCondLst>
+                                  <p:childTnLst>
+                                    <p:set>
+                                      <p:cBhvr>
+                                        <p:cTn id="202" dur="1" fill="hold">
+                                          <p:stCondLst>
+                                            <p:cond delay="0"/>
+                                          </p:stCondLst>
+                                        </p:cTn>
+                                        <p:tgtEl>
+                                          <p:spTgt spid="42"/>
+                                        </p:tgtEl>
+                                        <p:attrNameLst>
+                                          <p:attrName>style.visibility</p:attrName>
+                                        </p:attrNameLst>
+                                      </p:cBhvr>
+                                      <p:to>
+                                        <p:strVal val="visible"/>
+                                      </p:to>
+                                    </p:set>
+                                    <p:animEffect transition="in" filter="fade">
+                                      <p:cBhvr>
+                                        <p:cTn id="203" dur="600"/>
+                                        <p:tgtEl>
+                                          <p:spTgt spid="42"/>
+                                        </p:tgtEl>
+                                      </p:cBhvr>
+                                    </p:animEffect>
+                                    <p:anim calcmode="lin" valueType="num">
+                                      <p:cBhvr>
+                                        <p:cTn id="204" dur="600" decel="100000" fill="hold"/>
+                                        <p:tgtEl>
+                                          <p:spTgt spid="42"/>
+                                        </p:tgtEl>
+                                        <p:attrNameLst>
+                                          <p:attrName>ppt_x</p:attrName>
+                                        </p:attrNameLst>
+                                      </p:cBhvr>
+                                      <p:tavLst>
+                                        <p:tav tm="0">
+                                          <p:val>
+                                            <p:strVal val="#ppt_x"/>
+                                          </p:val>
+                                        </p:tav>
+                                        <p:tav tm="100000">
+                                          <p:val>
+                                            <p:strVal val="#ppt_x"/>
+                                          </p:val>
+                                        </p:tav>
+                                      </p:tavLst>
+                                    </p:anim>
+                                    <p:anim calcmode="lin" valueType="num">
+                                      <p:cBhvr>
+                                        <p:cTn id="205" dur="600" decel="100000" fill="hold"/>
+                                        <p:tgtEl>
+                                          <p:spTgt spid="42"/>
+                                        </p:tgtEl>
+                                        <p:attrNameLst>
+                                          <p:attrName>ppt_y</p:attrName>
+                                        </p:attrNameLst>
+                                      </p:cBhvr>
+                                      <p:tavLst>
+                                        <p:tav tm="0">
+                                          <p:val>
+                                            <p:strVal val="#ppt_y+.08"/>
+                                          </p:val>
+                                        </p:tav>
+                                        <p:tav tm="100000">
+                                          <p:val>
+                                            <p:strVal val="#ppt_y"/>
+                                          </p:val>
+                                        </p:tav>
+                                      </p:tavLst>
+                                    </p:anim>
+                                  </p:childTnLst>
+                                </p:cTn>
+                              </p:par>
+                              <p:par>
+                                <p:cTn id="211" presetID="42" presetClass="entr" presetSubtype="0" fill="hold" grpId="0" nodeType="withEffect">
+                                  <p:stCondLst>
+                                    <p:cond delay="1000"/>
+                                  </p:stCondLst>
+                                  <p:childTnLst>
+                                    <p:set>
+                                      <p:cBhvr>
+                                        <p:cTn id="207" dur="1" fill="hold">
+                                          <p:stCondLst>
+                                            <p:cond delay="0"/>
+                                          </p:stCondLst>
+                                        </p:cTn>
+                                        <p:tgtEl>
+                                          <p:spTgt spid="43"/>
+                                        </p:tgtEl>
+                                        <p:attrNameLst>
+                                          <p:attrName>style.visibility</p:attrName>
+                                        </p:attrNameLst>
+                                      </p:cBhvr>
+                                      <p:to>
+                                        <p:strVal val="visible"/>
+                                      </p:to>
+                                    </p:set>
+                                    <p:animEffect transition="in" filter="fade">
+                                      <p:cBhvr>
+                                        <p:cTn id="208" dur="600"/>
+                                        <p:tgtEl>
+                                          <p:spTgt spid="43"/>
+                                        </p:tgtEl>
+                                      </p:cBhvr>
+                                    </p:animEffect>
+                                    <p:anim calcmode="lin" valueType="num">
+                                      <p:cBhvr>
+                                        <p:cTn id="209" dur="600" decel="100000" fill="hold"/>
+                                        <p:tgtEl>
+                                          <p:spTgt spid="43"/>
+                                        </p:tgtEl>
+                                        <p:attrNameLst>
+                                          <p:attrName>ppt_x</p:attrName>
+                                        </p:attrNameLst>
+                                      </p:cBhvr>
+                                      <p:tavLst>
+                                        <p:tav tm="0">
+                                          <p:val>
+                                            <p:strVal val="#ppt_x"/>
+                                          </p:val>
+                                        </p:tav>
+                                        <p:tav tm="100000">
+                                          <p:val>
+                                            <p:strVal val="#ppt_x"/>
+                                          </p:val>
+                                        </p:tav>
+                                      </p:tavLst>
+                                    </p:anim>
+                                    <p:anim calcmode="lin" valueType="num">
+                                      <p:cBhvr>
+                                        <p:cTn id="210" dur="600" decel="100000" fill="hold"/>
+                                        <p:tgtEl>
+                                          <p:spTgt spid="43"/>
+                                        </p:tgtEl>
+                                        <p:attrNameLst>
+                                          <p:attrName>ppt_y</p:attrName>
+                                        </p:attrNameLst>
+                                      </p:cBhvr>
+                                      <p:tavLst>
+                                        <p:tav tm="0">
+                                          <p:val>
+                                            <p:strVal val="#ppt_y+.08"/>
+                                          </p:val>
+                                        </p:tav>
+                                        <p:tav tm="100000">
+                                          <p:val>
+                                            <p:strVal val="#ppt_y"/>
+                                          </p:val>
+                                        </p:tav>
+                                      </p:tavLst>
+                                    </p:anim>
+                                  </p:childTnLst>
+                                </p:cTn>
+                              </p:par>
+                              <p:par>
+                                <p:cTn id="216" presetID="42" presetClass="entr" presetSubtype="0" fill="hold" grpId="0" nodeType="withEffect">
+                                  <p:stCondLst>
+                                    <p:cond delay="1000"/>
+                                  </p:stCondLst>
+                                  <p:childTnLst>
+                                    <p:set>
+                                      <p:cBhvr>
+                                        <p:cTn id="212" dur="1" fill="hold">
+                                          <p:stCondLst>
+                                            <p:cond delay="0"/>
+                                          </p:stCondLst>
+                                        </p:cTn>
+                                        <p:tgtEl>
+                                          <p:spTgt spid="44"/>
+                                        </p:tgtEl>
+                                        <p:attrNameLst>
+                                          <p:attrName>style.visibility</p:attrName>
+                                        </p:attrNameLst>
+                                      </p:cBhvr>
+                                      <p:to>
+                                        <p:strVal val="visible"/>
+                                      </p:to>
+                                    </p:set>
+                                    <p:animEffect transition="in" filter="fade">
+                                      <p:cBhvr>
+                                        <p:cTn id="213" dur="600"/>
+                                        <p:tgtEl>
+                                          <p:spTgt spid="44"/>
+                                        </p:tgtEl>
+                                      </p:cBhvr>
+                                    </p:animEffect>
+                                    <p:anim calcmode="lin" valueType="num">
+                                      <p:cBhvr>
+                                        <p:cTn id="214" dur="600" decel="100000" fill="hold"/>
+                                        <p:tgtEl>
+                                          <p:spTgt spid="44"/>
+                                        </p:tgtEl>
+                                        <p:attrNameLst>
+                                          <p:attrName>ppt_x</p:attrName>
+                                        </p:attrNameLst>
+                                      </p:cBhvr>
+                                      <p:tavLst>
+                                        <p:tav tm="0">
+                                          <p:val>
+                                            <p:strVal val="#ppt_x"/>
+                                          </p:val>
+                                        </p:tav>
+                                        <p:tav tm="100000">
+                                          <p:val>
+                                            <p:strVal val="#ppt_x"/>
+                                          </p:val>
+                                        </p:tav>
+                                      </p:tavLst>
+                                    </p:anim>
+                                    <p:anim calcmode="lin" valueType="num">
+                                      <p:cBhvr>
+                                        <p:cTn id="215" dur="600" decel="100000" fill="hold"/>
+                                        <p:tgtEl>
+                                          <p:spTgt spid="44"/>
+                                        </p:tgtEl>
+                                        <p:attrNameLst>
+                                          <p:attrName>ppt_y</p:attrName>
+                                        </p:attrNameLst>
+                                      </p:cBhvr>
+                                      <p:tavLst>
+                                        <p:tav tm="0">
+                                          <p:val>
+                                            <p:strVal val="#ppt_y+.08"/>
+                                          </p:val>
+                                        </p:tav>
+                                        <p:tav tm="100000">
+                                          <p:val>
+                                            <p:strVal val="#ppt_y"/>
+                                          </p:val>
+                                        </p:tav>
+                                      </p:tavLst>
+                                    </p:anim>
+                                  </p:childTnLst>
+                                </p:cTn>
+                              </p:par>
+                              <p:par>
+                                <p:cTn id="221" presetID="42" presetClass="entr" presetSubtype="0" fill="hold" grpId="0" nodeType="withEffect">
+                                  <p:stCondLst>
+                                    <p:cond delay="1000"/>
+                                  </p:stCondLst>
+                                  <p:childTnLst>
+                                    <p:set>
+                                      <p:cBhvr>
+                                        <p:cTn id="217" dur="1" fill="hold">
+                                          <p:stCondLst>
+                                            <p:cond delay="0"/>
+                                          </p:stCondLst>
+                                        </p:cTn>
+                                        <p:tgtEl>
+                                          <p:spTgt spid="45"/>
+                                        </p:tgtEl>
+                                        <p:attrNameLst>
+                                          <p:attrName>style.visibility</p:attrName>
+                                        </p:attrNameLst>
+                                      </p:cBhvr>
+                                      <p:to>
+                                        <p:strVal val="visible"/>
+                                      </p:to>
+                                    </p:set>
+                                    <p:animEffect transition="in" filter="fade">
+                                      <p:cBhvr>
+                                        <p:cTn id="218" dur="600"/>
+                                        <p:tgtEl>
+                                          <p:spTgt spid="45"/>
+                                        </p:tgtEl>
+                                      </p:cBhvr>
+                                    </p:animEffect>
+                                    <p:anim calcmode="lin" valueType="num">
+                                      <p:cBhvr>
+                                        <p:cTn id="219" dur="600" decel="100000" fill="hold"/>
+                                        <p:tgtEl>
+                                          <p:spTgt spid="45"/>
+                                        </p:tgtEl>
+                                        <p:attrNameLst>
+                                          <p:attrName>ppt_x</p:attrName>
+                                        </p:attrNameLst>
+                                      </p:cBhvr>
+                                      <p:tavLst>
+                                        <p:tav tm="0">
+                                          <p:val>
+                                            <p:strVal val="#ppt_x"/>
+                                          </p:val>
+                                        </p:tav>
+                                        <p:tav tm="100000">
+                                          <p:val>
+                                            <p:strVal val="#ppt_x"/>
+                                          </p:val>
+                                        </p:tav>
+                                      </p:tavLst>
+                                    </p:anim>
+                                    <p:anim calcmode="lin" valueType="num">
+                                      <p:cBhvr>
+                                        <p:cTn id="220" dur="600" decel="100000" fill="hold"/>
+                                        <p:tgtEl>
+                                          <p:spTgt spid="45"/>
+                                        </p:tgtEl>
+                                        <p:attrNameLst>
+                                          <p:attrName>ppt_y</p:attrName>
+                                        </p:attrNameLst>
+                                      </p:cBhvr>
+                                      <p:tavLst>
+                                        <p:tav tm="0">
+                                          <p:val>
+                                            <p:strVal val="#ppt_y+.08"/>
+                                          </p:val>
+                                        </p:tav>
+                                        <p:tav tm="100000">
+                                          <p:val>
+                                            <p:strVal val="#ppt_y"/>
+                                          </p:val>
+                                        </p:tav>
+                                      </p:tavLst>
+                                    </p:anim>
+                                  </p:childTnLst>
+                                </p:cTn>
+                              </p:par>
+                              <p:par>
+                                <p:cTn id="226" presetID="42" presetClass="entr" presetSubtype="0" fill="hold" grpId="0" nodeType="withEffect">
+                                  <p:stCondLst>
+                                    <p:cond delay="1000"/>
+                                  </p:stCondLst>
+                                  <p:childTnLst>
+                                    <p:set>
+                                      <p:cBhvr>
+                                        <p:cTn id="222" dur="1" fill="hold">
+                                          <p:stCondLst>
+                                            <p:cond delay="0"/>
+                                          </p:stCondLst>
+                                        </p:cTn>
+                                        <p:tgtEl>
+                                          <p:spTgt spid="46"/>
+                                        </p:tgtEl>
+                                        <p:attrNameLst>
+                                          <p:attrName>style.visibility</p:attrName>
+                                        </p:attrNameLst>
+                                      </p:cBhvr>
+                                      <p:to>
+                                        <p:strVal val="visible"/>
+                                      </p:to>
+                                    </p:set>
+                                    <p:animEffect transition="in" filter="fade">
+                                      <p:cBhvr>
+                                        <p:cTn id="223" dur="600"/>
+                                        <p:tgtEl>
+                                          <p:spTgt spid="46"/>
+                                        </p:tgtEl>
+                                      </p:cBhvr>
+                                    </p:animEffect>
+                                    <p:anim calcmode="lin" valueType="num">
+                                      <p:cBhvr>
+                                        <p:cTn id="224" dur="600" decel="100000" fill="hold"/>
+                                        <p:tgtEl>
+                                          <p:spTgt spid="46"/>
+                                        </p:tgtEl>
+                                        <p:attrNameLst>
+                                          <p:attrName>ppt_x</p:attrName>
+                                        </p:attrNameLst>
+                                      </p:cBhvr>
+                                      <p:tavLst>
+                                        <p:tav tm="0">
+                                          <p:val>
+                                            <p:strVal val="#ppt_x"/>
+                                          </p:val>
+                                        </p:tav>
+                                        <p:tav tm="100000">
+                                          <p:val>
+                                            <p:strVal val="#ppt_x"/>
+                                          </p:val>
+                                        </p:tav>
+                                      </p:tavLst>
+                                    </p:anim>
+                                    <p:anim calcmode="lin" valueType="num">
+                                      <p:cBhvr>
+                                        <p:cTn id="225" dur="600" decel="100000" fill="hold"/>
+                                        <p:tgtEl>
+                                          <p:spTgt spid="46"/>
+                                        </p:tgtEl>
+                                        <p:attrNameLst>
+                                          <p:attrName>ppt_y</p:attrName>
+                                        </p:attrNameLst>
+                                      </p:cBhvr>
+                                      <p:tavLst>
+                                        <p:tav tm="0">
+                                          <p:val>
+                                            <p:strVal val="#ppt_y+.08"/>
+                                          </p:val>
+                                        </p:tav>
+                                        <p:tav tm="100000">
+                                          <p:val>
+                                            <p:strVal val="#ppt_y"/>
+                                          </p:val>
+                                        </p:tav>
+                                      </p:tavLst>
+                                    </p:anim>
+                                  </p:childTnLst>
+                                </p:cTn>
+                              </p:par>
+                              <p:par>
+                                <p:cTn id="231" presetID="42" presetClass="entr" presetSubtype="0" fill="hold" grpId="0" nodeType="withEffect">
+                                  <p:stCondLst>
+                                    <p:cond delay="1000"/>
+                                  </p:stCondLst>
+                                  <p:childTnLst>
+                                    <p:set>
+                                      <p:cBhvr>
+                                        <p:cTn id="227" dur="1" fill="hold">
+                                          <p:stCondLst>
+                                            <p:cond delay="0"/>
+                                          </p:stCondLst>
+                                        </p:cTn>
+                                        <p:tgtEl>
+                                          <p:spTgt spid="47"/>
+                                        </p:tgtEl>
+                                        <p:attrNameLst>
+                                          <p:attrName>style.visibility</p:attrName>
+                                        </p:attrNameLst>
+                                      </p:cBhvr>
+                                      <p:to>
+                                        <p:strVal val="visible"/>
+                                      </p:to>
+                                    </p:set>
+                                    <p:animEffect transition="in" filter="fade">
+                                      <p:cBhvr>
+                                        <p:cTn id="228" dur="600"/>
+                                        <p:tgtEl>
+                                          <p:spTgt spid="47"/>
+                                        </p:tgtEl>
+                                      </p:cBhvr>
+                                    </p:animEffect>
+                                    <p:anim calcmode="lin" valueType="num">
+                                      <p:cBhvr>
+                                        <p:cTn id="229" dur="600" decel="100000" fill="hold"/>
+                                        <p:tgtEl>
+                                          <p:spTgt spid="47"/>
+                                        </p:tgtEl>
+                                        <p:attrNameLst>
+                                          <p:attrName>ppt_x</p:attrName>
+                                        </p:attrNameLst>
+                                      </p:cBhvr>
+                                      <p:tavLst>
+                                        <p:tav tm="0">
+                                          <p:val>
+                                            <p:strVal val="#ppt_x"/>
+                                          </p:val>
+                                        </p:tav>
+                                        <p:tav tm="100000">
+                                          <p:val>
+                                            <p:strVal val="#ppt_x"/>
+                                          </p:val>
+                                        </p:tav>
+                                      </p:tavLst>
+                                    </p:anim>
+                                    <p:anim calcmode="lin" valueType="num">
+                                      <p:cBhvr>
+                                        <p:cTn id="230" dur="600" decel="100000" fill="hold"/>
+                                        <p:tgtEl>
+                                          <p:spTgt spid="47"/>
+                                        </p:tgtEl>
+                                        <p:attrNameLst>
+                                          <p:attrName>ppt_y</p:attrName>
+                                        </p:attrNameLst>
+                                      </p:cBhvr>
+                                      <p:tavLst>
+                                        <p:tav tm="0">
+                                          <p:val>
+                                            <p:strVal val="#ppt_y+.08"/>
+                                          </p:val>
+                                        </p:tav>
+                                        <p:tav tm="100000">
+                                          <p:val>
+                                            <p:strVal val="#ppt_y"/>
+                                          </p:val>
+                                        </p:tav>
+                                      </p:tavLst>
+                                    </p:anim>
+                                  </p:childTnLst>
+                                </p:cTn>
+                              </p:par>
+                              <p:par>
+                                <p:cTn id="234" presetID="10" presetClass="entr" presetSubtype="0" fill="hold" grpId="0" nodeType="withEffect">
                                   <p:stCondLst>
                                     <p:cond delay="1200"/>
                                   </p:stCondLst>
                                   <p:childTnLst>
                                     <p:set>
                                       <p:cBhvr>
-                                        <p:cTn id="182" dur="1" fill="hold">
+                                        <p:cTn id="232" dur="1" fill="hold">
                                           <p:stCondLst>
                                             <p:cond delay="0"/>
                                           </p:stCondLst>
                                         </p:cTn>
                                         <p:tgtEl>
-                                          <p:spTgt spid="25"/>
+                                          <p:spTgt spid="48"/>
                                         </p:tgtEl>
                                         <p:attrNameLst>
                                           <p:attrName>style.visibility</p:attrName>
@@ -23633,7 +24794,42 @@
                                     </p:set>
                                     <p:animEffect transition="in" filter="fade">
                                       <p:cBhvr>
-                                        <p:cTn id="183" dur="500"/>
+                                        <p:cTn id="233" dur="500"/>
+                                        <p:tgtEl>
+                                          <p:spTgt spid="48"/>
+                                        </p:tgtEl>
+                                      </p:cBhvr>
+                                    </p:animEffect>
+                                  </p:childTnLst>
+                                </p:cTn>
+                              </p:par>
+                              <p:par>
+                                <p:cTn id="237" presetID="10" presetClass="entr" presetSubtype="0" fill="hold" grpId="0" nodeType="withEffect">
+                                  <p:stCondLst>
+                                    <p:cond delay="1400"/>
+                                  </p:stCondLst>
+                                  <p:childTnLst>
+                                    <p:set>
+                                      <p:cBhvr>
+                                        <p:cTn id="235" dur="1" fill="hold">
+                                          <p:stCondLst>
+                                            <p:cond delay="0"/>
+                                          </p:stCondLst>
+                                        </p:cTn>
+                                        <p:tgtEl>
+                                          <p:spTgt spid="25"/>
+                                        </p:tgtEl>
+                                        <p:attrNameLst>
+                                          <p:attrName>style.visibility</p:attrName>
+                                        </p:attrNameLst>
+                                      </p:cBhvr>
+                                      <p:to>
+                                        <p:strVal val="visible"/>
+                                      </p:to>
+                                    </p:set>
+                                    <p:animEffect transition="in" filter="fade">
+                                      <p:cBhvr>
+                                        <p:cTn id="236" dur="500"/>
                                         <p:tgtEl>
                                           <p:spTgt spid="25"/>
                                         </p:tgtEl>
@@ -23674,28 +24870,34 @@
       <p:bldP spid="5" grpId="0" animBg="1"/>
       <p:bldP spid="6" grpId="0" animBg="1"/>
       <p:bldP spid="7" grpId="0" animBg="1"/>
-      <p:bldP spid="8" grpId="0" animBg="1"/>
       <p:bldP spid="9" grpId="0" animBg="1"/>
-      <p:bldP spid="12" grpId="0" animBg="1"/>
-      <p:bldP spid="13" grpId="0" animBg="1"/>
+      <p:bldP spid="10" grpId="0" animBg="1"/>
+      <p:bldP spid="11" grpId="0" animBg="1"/>
       <p:bldP spid="14" grpId="0" animBg="1"/>
       <p:bldP spid="15" grpId="0" animBg="1"/>
       <p:bldP spid="16" grpId="0" animBg="1"/>
+      <p:bldP spid="18" grpId="0" animBg="1"/>
       <p:bldP spid="19" grpId="0" animBg="1"/>
       <p:bldP spid="20" grpId="0" animBg="1"/>
-      <p:bldP spid="21" grpId="0" animBg="1"/>
-      <p:bldP spid="22" grpId="0" animBg="1"/>
       <p:bldP spid="23" grpId="0" animBg="1"/>
-      <p:bldP spid="26" grpId="0" animBg="1"/>
+      <p:bldP spid="24" grpId="0" animBg="1"/>
+      <p:bldP spid="25" grpId="0" animBg="1"/>
       <p:bldP spid="27" grpId="0" animBg="1"/>
       <p:bldP spid="28" grpId="0" animBg="1"/>
       <p:bldP spid="29" grpId="0" animBg="1"/>
-      <p:bldP spid="30" grpId="0" animBg="1"/>
+      <p:bldP spid="32" grpId="0" animBg="1"/>
       <p:bldP spid="33" grpId="0" animBg="1"/>
       <p:bldP spid="34" grpId="0" animBg="1"/>
-      <p:bldP spid="35" grpId="0" animBg="1"/>
       <p:bldP spid="36" grpId="0" animBg="1"/>
       <p:bldP spid="37" grpId="0" animBg="1"/>
+      <p:bldP spid="38" grpId="0" animBg="1"/>
+      <p:bldP spid="41" grpId="0" animBg="1"/>
+      <p:bldP spid="42" grpId="0" animBg="1"/>
+      <p:bldP spid="43" grpId="0" animBg="1"/>
+      <p:bldP spid="45" grpId="0" animBg="1"/>
+      <p:bldP spid="46" grpId="0" animBg="1"/>
+      <p:bldP spid="47" grpId="0" animBg="1"/>
+      <p:bldP spid="48" grpId="0" animBg="1"/>
       <p:bldP spid="25" grpId="0" animBg="1"/>
     </p:bldLst>
   </p:timing>

</xml_diff>